<commit_message>
adds more extensive working with others exercise
</commit_message>
<xml_diff>
--- a/Version Control/Lesson 01 - Intro to Version Control/Intro to Version Control.pptx
+++ b/Version Control/Lesson 01 - Intro to Version Control/Intro to Version Control.pptx
@@ -46254,10 +46254,10 @@
               <a:buChar char="•"/>
             </a:pPr>
             <a:r>
-              <a:rPr lang="en-US"/>
+              <a:rPr lang="en-US" dirty="0"/>
               <a:t>Made by Linus Torvalds</a:t>
             </a:r>
-            <a:endParaRPr/>
+            <a:endParaRPr dirty="0"/>
           </a:p>
           <a:p>
             <a:pPr marL="228600" lvl="0" indent="-228600" algn="l" rtl="0">
@@ -46277,14 +46277,14 @@
               <a:buChar char="•"/>
             </a:pPr>
             <a:r>
-              <a:rPr lang="en-US"/>
+              <a:rPr lang="en-US" dirty="0"/>
               <a:t>Wrote the basics in about two weeks</a:t>
             </a:r>
             <a:r>
-              <a:rPr lang="en-US" baseline="30000"/>
+              <a:rPr lang="en-US" baseline="30000" dirty="0"/>
               <a:t>1</a:t>
             </a:r>
-            <a:endParaRPr/>
+            <a:endParaRPr dirty="0"/>
           </a:p>
           <a:p>
             <a:pPr marL="228600" lvl="0" indent="-228600" algn="l" rtl="0">
@@ -46304,8 +46304,53 @@
               <a:buChar char="•"/>
             </a:pPr>
             <a:r>
+              <a:rPr lang="en-US" dirty="0"/>
+              <a:t>The first commit was for git itself</a:t>
+            </a:r>
+          </a:p>
+          <a:p>
+            <a:pPr marL="228600" lvl="0" indent="-228600" algn="l" rtl="0">
+              <a:lnSpc>
+                <a:spcPct val="90000"/>
+              </a:lnSpc>
+              <a:spcBef>
+                <a:spcPts val="1000"/>
+              </a:spcBef>
+              <a:spcAft>
+                <a:spcPts val="0"/>
+              </a:spcAft>
+              <a:buClr>
+                <a:schemeClr val="dk1"/>
+              </a:buClr>
+              <a:buSzPts val="2800"/>
+              <a:buChar char="•"/>
+            </a:pPr>
+            <a:endParaRPr lang="en-US" dirty="0"/>
+          </a:p>
+          <a:p>
+            <a:pPr marL="228600" lvl="0" indent="-228600" algn="l" rtl="0">
+              <a:lnSpc>
+                <a:spcPct val="90000"/>
+              </a:lnSpc>
+              <a:spcBef>
+                <a:spcPts val="1000"/>
+              </a:spcBef>
+              <a:spcAft>
+                <a:spcPts val="0"/>
+              </a:spcAft>
+              <a:buClr>
+                <a:schemeClr val="dk1"/>
+              </a:buClr>
+              <a:buSzPts val="2800"/>
+              <a:buChar char="•"/>
+            </a:pPr>
+            <a:r>
+              <a:rPr lang="en-US" dirty="0"/>
+              <a:t>What is git and what </a:t>
+            </a:r>
+            <a:r>
               <a:rPr lang="en-US"/>
-              <a:t>The first commit was for git itself</a:t>
+              <a:t>is GitHub?</a:t>
             </a:r>
             <a:endParaRPr/>
           </a:p>

</xml_diff>